<commit_message>
chore: checkpoint C07 integration and C08 alignment
</commit_message>
<xml_diff>
--- a/Doc/cluster_analysis/C02_Chip_Acquisition/C02_Chip_Acquisition_260430233213_Cluster2_Readiness_Review_v001.pptx
+++ b/Doc/cluster_analysis/C02_Chip_Acquisition/C02_Chip_Acquisition_260430233213_Cluster2_Readiness_Review_v001.pptx
@@ -4,6 +4,9 @@
   <p:sldMasterIdLst>
     <p:sldMasterId id="2147483648" r:id="rId1"/>
   </p:sldMasterIdLst>
+  <p:notesMasterIdLst>
+    <p:notesMasterId r:id="rId9"/>
+  </p:notesMasterIdLst>
   <p:sldIdLst>
     <p:sldId id="256" r:id="rId2"/>
     <p:sldId id="257" r:id="rId3"/>
@@ -13,9 +16,6 @@
     <p:sldId id="261" r:id="rId7"/>
     <p:sldId id="262" r:id="rId8"/>
   </p:sldIdLst>
-  <p:notesMasterIdLst>
-    <p:notesMasterId r:id="rId9"/>
-  </p:notesMasterIdLst>
   <p:sldSz cx="12192000" cy="6858000"/>
   <p:notesSz cx="6858000" cy="12192000"/>
   <p:defaultTextStyle>
@@ -110,6 +110,11 @@
       </a:defRPr>
     </a:lvl9pPr>
   </p:defaultTextStyle>
+  <p:extLst>
+    <p:ext uri="{EFAFB233-063F-42B5-8137-9DF3F51BA10A}">
+      <p15:sldGuideLst xmlns:p15="http://schemas.microsoft.com/office/powerpoint/2012/main"/>
+    </p:ext>
+  </p:extLst>
 </p:presentation>
 </file>
 
@@ -135,240 +140,16 @@
           <a:chExt cx="0" cy="0"/>
         </a:xfrm>
       </p:grpSpPr>
-      <p:sp>
-        <p:nvSpPr>
-          <p:cNvPr id="2" name="Header Placeholder 1"/>
-          <p:cNvSpPr>
-            <a:spLocks noGrp="1"/>
-          </p:cNvSpPr>
-          <p:nvPr>
-            <p:ph type="hdr" sz="quarter"/>
-          </p:nvPr>
-        </p:nvSpPr>
-        <p:spPr>
-          <a:xfrm>
-            <a:off x="0" y="0"/>
-            <a:ext cx="2971800" cy="458788"/>
-          </a:xfrm>
-          <a:prstGeom prst="rect">
-            <a:avLst/>
-          </a:prstGeom>
-        </p:spPr>
-        <p:txBody>
-          <a:bodyPr vert="horz" lIns="91440" tIns="45720" rIns="91440" bIns="45720" rtlCol="0"/>
-          <a:lstStyle>
-            <a:lvl1pPr algn="l">
-              <a:defRPr sz="1200"/>
-            </a:lvl1pPr>
-          </a:lstStyle>
-          <a:p>
-            <a:endParaRPr lang="en-US"/>
-          </a:p>
-        </p:txBody>
-      </p:sp>
-      <p:sp>
-        <p:nvSpPr>
-          <p:cNvPr id="3" name="Date Placeholder 2"/>
-          <p:cNvSpPr>
-            <a:spLocks noGrp="1"/>
-          </p:cNvSpPr>
-          <p:nvPr>
-            <p:ph type="dt" idx="1"/>
-          </p:nvPr>
-        </p:nvSpPr>
-        <p:spPr>
-          <a:xfrm>
-            <a:off x="3884613" y="0"/>
-            <a:ext cx="2971800" cy="458788"/>
-          </a:xfrm>
-          <a:prstGeom prst="rect">
-            <a:avLst/>
-          </a:prstGeom>
-        </p:spPr>
-        <p:txBody>
-          <a:bodyPr vert="horz" lIns="91440" tIns="45720" rIns="91440" bIns="45720" rtlCol="0"/>
-          <a:lstStyle>
-            <a:lvl1pPr algn="r">
-              <a:defRPr sz="1200"/>
-            </a:lvl1pPr>
-          </a:lstStyle>
-          <a:p>
-            <a:fld id="{5282F153-3F37-0F45-9E97-73ACFA13230C}" type="datetimeFigureOut">
-              <a:rPr lang="en-US"/>
-              <a:t>7/23/19</a:t>
-            </a:fld>
-            <a:endParaRPr lang="en-US"/>
-          </a:p>
-        </p:txBody>
-      </p:sp>
-      <p:sp>
-        <p:nvSpPr>
-          <p:cNvPr id="4" name="Slide Image Placeholder 3"/>
-          <p:cNvSpPr>
-            <a:spLocks noGrp="1" noRot="1" noChangeAspect="1"/>
-          </p:cNvSpPr>
-          <p:nvPr>
-            <p:ph type="sldImg" idx="2"/>
-          </p:nvPr>
-        </p:nvSpPr>
-        <p:spPr>
-          <a:xfrm>
-            <a:off x="685800" y="1143000"/>
-            <a:ext cx="5486400" cy="3086100"/>
-          </a:xfrm>
-          <a:prstGeom prst="rect">
-            <a:avLst/>
-          </a:prstGeom>
-          <a:noFill/>
-          <a:ln w="12700">
-            <a:solidFill>
-              <a:prstClr val="black"/>
-            </a:solidFill>
-          </a:ln>
-        </p:spPr>
-        <p:txBody>
-          <a:bodyPr vert="horz" lIns="91440" tIns="45720" rIns="91440" bIns="45720" rtlCol="0" anchor="ctr"/>
-          <a:lstStyle/>
-          <a:p>
-            <a:endParaRPr lang="en-US"/>
-          </a:p>
-        </p:txBody>
-      </p:sp>
-      <p:sp>
-        <p:nvSpPr>
-          <p:cNvPr id="5" name="Notes Placeholder 4"/>
-          <p:cNvSpPr>
-            <a:spLocks noGrp="1"/>
-          </p:cNvSpPr>
-          <p:nvPr>
-            <p:ph type="body" sz="quarter" idx="3"/>
-          </p:nvPr>
-        </p:nvSpPr>
-        <p:spPr>
-          <a:xfrm>
-            <a:off x="685800" y="4400550"/>
-            <a:ext cx="5486400" cy="3600450"/>
-          </a:xfrm>
-          <a:prstGeom prst="rect">
-            <a:avLst/>
-          </a:prstGeom>
-        </p:spPr>
-        <p:txBody>
-          <a:bodyPr vert="horz" lIns="91440" tIns="45720" rIns="91440" bIns="45720" rtlCol="0"/>
-          <a:lstStyle/>
-          <a:p>
-            <a:pPr lvl="0"/>
-            <a:r>
-              <a:rPr lang="en-US"/>
-              <a:t>Click to edit Master text styles</a:t>
-            </a:r>
-          </a:p>
-          <a:p>
-            <a:pPr lvl="1"/>
-            <a:r>
-              <a:rPr lang="en-US"/>
-              <a:t>Second level</a:t>
-            </a:r>
-          </a:p>
-          <a:p>
-            <a:pPr lvl="2"/>
-            <a:r>
-              <a:rPr lang="en-US"/>
-              <a:t>Third level</a:t>
-            </a:r>
-          </a:p>
-          <a:p>
-            <a:pPr lvl="3"/>
-            <a:r>
-              <a:rPr lang="en-US"/>
-              <a:t>Fourth level</a:t>
-            </a:r>
-          </a:p>
-          <a:p>
-            <a:pPr lvl="4"/>
-            <a:r>
-              <a:rPr lang="en-US"/>
-              <a:t>Fifth level</a:t>
-            </a:r>
-          </a:p>
-        </p:txBody>
-      </p:sp>
-      <p:sp>
-        <p:nvSpPr>
-          <p:cNvPr id="6" name="Footer Placeholder 5"/>
-          <p:cNvSpPr>
-            <a:spLocks noGrp="1"/>
-          </p:cNvSpPr>
-          <p:nvPr>
-            <p:ph type="ftr" sz="quarter" idx="4"/>
-          </p:nvPr>
-        </p:nvSpPr>
-        <p:spPr>
-          <a:xfrm>
-            <a:off x="0" y="8685213"/>
-            <a:ext cx="2971800" cy="458787"/>
-          </a:xfrm>
-          <a:prstGeom prst="rect">
-            <a:avLst/>
-          </a:prstGeom>
-        </p:spPr>
-        <p:txBody>
-          <a:bodyPr vert="horz" lIns="91440" tIns="45720" rIns="91440" bIns="45720" rtlCol="0" anchor="b"/>
-          <a:lstStyle>
-            <a:lvl1pPr algn="l">
-              <a:defRPr sz="1200"/>
-            </a:lvl1pPr>
-          </a:lstStyle>
-          <a:p>
-            <a:endParaRPr lang="en-US"/>
-          </a:p>
-        </p:txBody>
-      </p:sp>
-      <p:sp>
-        <p:nvSpPr>
-          <p:cNvPr id="7" name="Slide Number Placeholder 6"/>
-          <p:cNvSpPr>
-            <a:spLocks noGrp="1"/>
-          </p:cNvSpPr>
-          <p:nvPr>
-            <p:ph type="sldNum" sz="quarter" idx="5"/>
-          </p:nvPr>
-        </p:nvSpPr>
-        <p:spPr>
-          <a:xfrm>
-            <a:off x="3884613" y="8685213"/>
-            <a:ext cx="2971800" cy="458787"/>
-          </a:xfrm>
-          <a:prstGeom prst="rect">
-            <a:avLst/>
-          </a:prstGeom>
-        </p:spPr>
-        <p:txBody>
-          <a:bodyPr vert="horz" lIns="91440" tIns="45720" rIns="91440" bIns="45720" rtlCol="0" anchor="b"/>
-          <a:lstStyle>
-            <a:lvl1pPr algn="r">
-              <a:defRPr sz="1200"/>
-            </a:lvl1pPr>
-          </a:lstStyle>
-          <a:p>
-            <a:fld id="{CE5E9CC1-C706-0F49-92D6-E571CC5EEA8F}" type="slidenum">
-              <a:rPr lang="en-US"/>
-              <a:t>‹#›</a:t>
-            </a:fld>
-            <a:endParaRPr lang="en-US"/>
-          </a:p>
-        </p:txBody>
-      </p:sp>
     </p:spTree>
     <p:extLst>
       <p:ext uri="{BB962C8B-B14F-4D97-AF65-F5344CB8AC3E}">
-        <p14:creationId xmlns:p14="http://schemas.microsoft.com/office/powerpoint/2010/main" val="1024086991"/>
+        <p14:creationId xmlns:p14="http://schemas.microsoft.com/office/powerpoint/2010/main" val="3565823917"/>
       </p:ext>
     </p:extLst>
   </p:cSld>
   <p:clrMap bg1="lt1" tx1="dk1" bg2="lt2" tx2="dk2" accent1="accent1" accent2="accent2" accent3="accent3" accent4="accent4" accent5="accent5" accent6="accent6" hlink="hlink" folHlink="folHlink"/>
   <p:notesStyle>
-    <a:lvl1pPr marL="0" algn="l" defTabSz="914400" rtl="0" eaLnBrk="1" latinLnBrk="0" hangingPunct="1">
+    <a:lvl1pPr marL="0" algn="l" defTabSz="914400" rtl="0" eaLnBrk="1" latinLnBrk="1" hangingPunct="1">
       <a:defRPr sz="1200" kern="1200">
         <a:solidFill>
           <a:schemeClr val="tx1"/>
@@ -378,7 +159,7 @@
         <a:cs typeface="+mn-cs"/>
       </a:defRPr>
     </a:lvl1pPr>
-    <a:lvl2pPr marL="457200" algn="l" defTabSz="914400" rtl="0" eaLnBrk="1" latinLnBrk="0" hangingPunct="1">
+    <a:lvl2pPr marL="457200" algn="l" defTabSz="914400" rtl="0" eaLnBrk="1" latinLnBrk="1" hangingPunct="1">
       <a:defRPr sz="1200" kern="1200">
         <a:solidFill>
           <a:schemeClr val="tx1"/>
@@ -388,7 +169,7 @@
         <a:cs typeface="+mn-cs"/>
       </a:defRPr>
     </a:lvl2pPr>
-    <a:lvl3pPr marL="914400" algn="l" defTabSz="914400" rtl="0" eaLnBrk="1" latinLnBrk="0" hangingPunct="1">
+    <a:lvl3pPr marL="914400" algn="l" defTabSz="914400" rtl="0" eaLnBrk="1" latinLnBrk="1" hangingPunct="1">
       <a:defRPr sz="1200" kern="1200">
         <a:solidFill>
           <a:schemeClr val="tx1"/>
@@ -398,7 +179,7 @@
         <a:cs typeface="+mn-cs"/>
       </a:defRPr>
     </a:lvl3pPr>
-    <a:lvl4pPr marL="1371600" algn="l" defTabSz="914400" rtl="0" eaLnBrk="1" latinLnBrk="0" hangingPunct="1">
+    <a:lvl4pPr marL="1371600" algn="l" defTabSz="914400" rtl="0" eaLnBrk="1" latinLnBrk="1" hangingPunct="1">
       <a:defRPr sz="1200" kern="1200">
         <a:solidFill>
           <a:schemeClr val="tx1"/>
@@ -408,7 +189,7 @@
         <a:cs typeface="+mn-cs"/>
       </a:defRPr>
     </a:lvl4pPr>
-    <a:lvl5pPr marL="1828800" algn="l" defTabSz="914400" rtl="0" eaLnBrk="1" latinLnBrk="0" hangingPunct="1">
+    <a:lvl5pPr marL="1828800" algn="l" defTabSz="914400" rtl="0" eaLnBrk="1" latinLnBrk="1" hangingPunct="1">
       <a:defRPr sz="1200" kern="1200">
         <a:solidFill>
           <a:schemeClr val="tx1"/>
@@ -418,7 +199,7 @@
         <a:cs typeface="+mn-cs"/>
       </a:defRPr>
     </a:lvl5pPr>
-    <a:lvl6pPr marL="2286000" algn="l" defTabSz="914400" rtl="0" eaLnBrk="1" latinLnBrk="0" hangingPunct="1">
+    <a:lvl6pPr marL="2286000" algn="l" defTabSz="914400" rtl="0" eaLnBrk="1" latinLnBrk="1" hangingPunct="1">
       <a:defRPr sz="1200" kern="1200">
         <a:solidFill>
           <a:schemeClr val="tx1"/>
@@ -428,7 +209,7 @@
         <a:cs typeface="+mn-cs"/>
       </a:defRPr>
     </a:lvl6pPr>
-    <a:lvl7pPr marL="2743200" algn="l" defTabSz="914400" rtl="0" eaLnBrk="1" latinLnBrk="0" hangingPunct="1">
+    <a:lvl7pPr marL="2743200" algn="l" defTabSz="914400" rtl="0" eaLnBrk="1" latinLnBrk="1" hangingPunct="1">
       <a:defRPr sz="1200" kern="1200">
         <a:solidFill>
           <a:schemeClr val="tx1"/>
@@ -438,7 +219,7 @@
         <a:cs typeface="+mn-cs"/>
       </a:defRPr>
     </a:lvl7pPr>
-    <a:lvl8pPr marL="3200400" algn="l" defTabSz="914400" rtl="0" eaLnBrk="1" latinLnBrk="0" hangingPunct="1">
+    <a:lvl8pPr marL="3200400" algn="l" defTabSz="914400" rtl="0" eaLnBrk="1" latinLnBrk="1" hangingPunct="1">
       <a:defRPr sz="1200" kern="1200">
         <a:solidFill>
           <a:schemeClr val="tx1"/>
@@ -448,7 +229,7 @@
         <a:cs typeface="+mn-cs"/>
       </a:defRPr>
     </a:lvl8pPr>
-    <a:lvl9pPr marL="3657600" algn="l" defTabSz="914400" rtl="0" eaLnBrk="1" latinLnBrk="0" hangingPunct="1">
+    <a:lvl9pPr marL="3657600" algn="l" defTabSz="914400" rtl="0" eaLnBrk="1" latinLnBrk="1" hangingPunct="1">
       <a:defRPr sz="1200" kern="1200">
         <a:solidFill>
           <a:schemeClr val="tx1"/>
@@ -506,10 +287,6 @@
           <a:bodyPr/>
           <a:lstStyle/>
           <a:p>
-            <a:r>
-              <a:rPr lang="en-US" dirty="0"/>
-              <a:t/>
-            </a:r>
             <a:endParaRPr lang="en-US" dirty="0"/>
           </a:p>
         </p:txBody>
@@ -594,10 +371,6 @@
           <a:bodyPr/>
           <a:lstStyle/>
           <a:p>
-            <a:r>
-              <a:rPr lang="en-US" dirty="0"/>
-              <a:t/>
-            </a:r>
             <a:endParaRPr lang="en-US" dirty="0"/>
           </a:p>
         </p:txBody>
@@ -682,10 +455,6 @@
           <a:bodyPr/>
           <a:lstStyle/>
           <a:p>
-            <a:r>
-              <a:rPr lang="en-US" dirty="0"/>
-              <a:t/>
-            </a:r>
             <a:endParaRPr lang="en-US" dirty="0"/>
           </a:p>
         </p:txBody>
@@ -770,10 +539,6 @@
           <a:bodyPr/>
           <a:lstStyle/>
           <a:p>
-            <a:r>
-              <a:rPr lang="en-US" dirty="0"/>
-              <a:t/>
-            </a:r>
             <a:endParaRPr lang="en-US" dirty="0"/>
           </a:p>
         </p:txBody>
@@ -858,10 +623,6 @@
           <a:bodyPr/>
           <a:lstStyle/>
           <a:p>
-            <a:r>
-              <a:rPr lang="en-US" dirty="0"/>
-              <a:t/>
-            </a:r>
             <a:endParaRPr lang="en-US" dirty="0"/>
           </a:p>
         </p:txBody>
@@ -946,10 +707,6 @@
           <a:bodyPr/>
           <a:lstStyle/>
           <a:p>
-            <a:r>
-              <a:rPr lang="en-US" dirty="0"/>
-              <a:t/>
-            </a:r>
             <a:endParaRPr lang="en-US" dirty="0"/>
           </a:p>
         </p:txBody>
@@ -1034,10 +791,6 @@
           <a:bodyPr/>
           <a:lstStyle/>
           <a:p>
-            <a:r>
-              <a:rPr lang="en-US" dirty="0"/>
-              <a:t/>
-            </a:r>
             <a:endParaRPr lang="en-US" dirty="0"/>
           </a:p>
         </p:txBody>
@@ -1111,6 +864,11 @@
 <file path=ppt/slideMasters/slideMaster1.xml><?xml version="1.0" encoding="utf-8"?>
 <p:sldMaster xmlns:a="http://schemas.openxmlformats.org/drawingml/2006/main" xmlns:r="http://schemas.openxmlformats.org/officeDocument/2006/relationships" xmlns:p="http://schemas.openxmlformats.org/presentationml/2006/main">
   <p:cSld>
+    <p:bg>
+      <p:bgRef idx="1001">
+        <a:schemeClr val="bg1"/>
+      </p:bgRef>
+    </p:bg>
     <p:spTree>
       <p:nvGrpSpPr>
         <p:cNvPr id="1" name=""/>
@@ -1393,6 +1151,7 @@
         <a:solidFill>
           <a:srgbClr val="F8FAFC"/>
         </a:solidFill>
+        <a:effectLst/>
       </p:bgPr>
     </p:bg>
     <p:spTree>
@@ -1432,7 +1191,7 @@
           </a:bodyPr>
           <a:lstStyle/>
           <a:p>
-            <a:pPr indent="0" marL="0">
+            <a:pPr marL="0" indent="0">
               <a:buNone/>
             </a:pPr>
             <a:r>
@@ -1473,7 +1232,7 @@
           </a:bodyPr>
           <a:lstStyle/>
           <a:p>
-            <a:pPr indent="0" marL="0">
+            <a:pPr marL="0" indent="0">
               <a:buNone/>
             </a:pPr>
             <a:r>
@@ -1564,7 +1323,7 @@
           </a:bodyPr>
           <a:lstStyle/>
           <a:p>
-            <a:pPr algn="ctr" indent="0" marL="0">
+            <a:pPr marL="0" indent="0" algn="ctr">
               <a:buNone/>
             </a:pPr>
             <a:r>
@@ -1581,7 +1340,7 @@
             <a:endParaRPr lang="en-US" sz="1700" dirty="0"/>
           </a:p>
           <a:p>
-            <a:pPr algn="ctr" indent="0" marL="0">
+            <a:pPr marL="0" indent="0" algn="ctr">
               <a:buNone/>
             </a:pPr>
             <a:r>
@@ -1649,7 +1408,7 @@
           </a:bodyPr>
           <a:lstStyle/>
           <a:p>
-            <a:pPr algn="ctr" indent="0" marL="0">
+            <a:pPr marL="0" indent="0" algn="ctr">
               <a:buNone/>
             </a:pPr>
             <a:r>
@@ -1666,7 +1425,7 @@
             <a:endParaRPr lang="en-US" sz="1600" dirty="0"/>
           </a:p>
           <a:p>
-            <a:pPr algn="ctr" indent="0" marL="0">
+            <a:pPr marL="0" indent="0" algn="ctr">
               <a:buNone/>
             </a:pPr>
             <a:r>
@@ -1734,7 +1493,7 @@
           </a:bodyPr>
           <a:lstStyle/>
           <a:p>
-            <a:pPr algn="ctr" indent="0" marL="0">
+            <a:pPr marL="0" indent="0" algn="ctr">
               <a:buNone/>
             </a:pPr>
             <a:r>
@@ -1751,7 +1510,7 @@
             <a:endParaRPr lang="en-US" sz="1600" dirty="0"/>
           </a:p>
           <a:p>
-            <a:pPr algn="ctr" indent="0" marL="0">
+            <a:pPr marL="0" indent="0" algn="ctr">
               <a:buNone/>
             </a:pPr>
             <a:r>
@@ -1792,7 +1551,7 @@
           </a:bodyPr>
           <a:lstStyle/>
           <a:p>
-            <a:pPr algn="ctr" indent="0" marL="0">
+            <a:pPr marL="0" indent="0" algn="ctr">
               <a:buNone/>
             </a:pPr>
             <a:r>
@@ -1860,7 +1619,7 @@
           </a:bodyPr>
           <a:lstStyle/>
           <a:p>
-            <a:pPr algn="ctr" indent="0" marL="0">
+            <a:pPr marL="0" indent="0" algn="ctr">
               <a:buNone/>
             </a:pPr>
             <a:r>
@@ -1877,7 +1636,7 @@
             <a:endParaRPr lang="en-US" sz="1200" dirty="0"/>
           </a:p>
           <a:p>
-            <a:pPr algn="ctr" indent="0" marL="0">
+            <a:pPr marL="0" indent="0" algn="ctr">
               <a:buNone/>
             </a:pPr>
             <a:r>
@@ -1945,7 +1704,7 @@
           </a:bodyPr>
           <a:lstStyle/>
           <a:p>
-            <a:pPr algn="ctr" indent="0" marL="0">
+            <a:pPr marL="0" indent="0" algn="ctr">
               <a:buNone/>
             </a:pPr>
             <a:r>
@@ -1962,7 +1721,7 @@
             <a:endParaRPr lang="en-US" sz="1200" dirty="0"/>
           </a:p>
           <a:p>
-            <a:pPr algn="ctr" indent="0" marL="0">
+            <a:pPr marL="0" indent="0" algn="ctr">
               <a:buNone/>
             </a:pPr>
             <a:r>
@@ -2030,7 +1789,7 @@
           </a:bodyPr>
           <a:lstStyle/>
           <a:p>
-            <a:pPr algn="ctr" indent="0" marL="0">
+            <a:pPr marL="0" indent="0" algn="ctr">
               <a:buNone/>
             </a:pPr>
             <a:r>
@@ -2047,7 +1806,7 @@
             <a:endParaRPr lang="en-US" sz="1200" dirty="0"/>
           </a:p>
           <a:p>
-            <a:pPr algn="ctr" indent="0" marL="0">
+            <a:pPr marL="0" indent="0" algn="ctr">
               <a:buNone/>
             </a:pPr>
             <a:r>
@@ -2088,7 +1847,7 @@
           </a:bodyPr>
           <a:lstStyle/>
           <a:p>
-            <a:pPr algn="ctr" indent="0" marL="0">
+            <a:pPr marL="0" indent="0" algn="ctr">
               <a:buNone/>
             </a:pPr>
             <a:r>
@@ -2122,6 +1881,7 @@
         <a:solidFill>
           <a:srgbClr val="F8FAFC"/>
         </a:solidFill>
+        <a:effectLst/>
       </p:bgPr>
     </p:bg>
     <p:spTree>
@@ -2161,7 +1921,7 @@
           </a:bodyPr>
           <a:lstStyle/>
           <a:p>
-            <a:pPr indent="0" marL="0">
+            <a:pPr marL="0" indent="0">
               <a:buNone/>
             </a:pPr>
             <a:r>
@@ -2202,7 +1962,7 @@
           </a:bodyPr>
           <a:lstStyle/>
           <a:p>
-            <a:pPr indent="0" marL="0">
+            <a:pPr marL="0" indent="0">
               <a:buNone/>
             </a:pPr>
             <a:r>
@@ -2293,7 +2053,7 @@
           </a:bodyPr>
           <a:lstStyle/>
           <a:p>
-            <a:pPr algn="ctr" indent="0" marL="0">
+            <a:pPr marL="0" indent="0" algn="ctr">
               <a:buNone/>
             </a:pPr>
             <a:r>
@@ -2310,7 +2070,7 @@
             <a:endParaRPr lang="en-US" sz="950" dirty="0"/>
           </a:p>
           <a:p>
-            <a:pPr algn="ctr" indent="0" marL="0">
+            <a:pPr marL="0" indent="0" algn="ctr">
               <a:buNone/>
             </a:pPr>
             <a:r>
@@ -2378,7 +2138,7 @@
           </a:bodyPr>
           <a:lstStyle/>
           <a:p>
-            <a:pPr algn="ctr" indent="0" marL="0">
+            <a:pPr marL="0" indent="0" algn="ctr">
               <a:buNone/>
             </a:pPr>
             <a:r>
@@ -2395,7 +2155,7 @@
             <a:endParaRPr lang="en-US" sz="950" dirty="0"/>
           </a:p>
           <a:p>
-            <a:pPr algn="ctr" indent="0" marL="0">
+            <a:pPr marL="0" indent="0" algn="ctr">
               <a:buNone/>
             </a:pPr>
             <a:r>
@@ -2463,7 +2223,7 @@
           </a:bodyPr>
           <a:lstStyle/>
           <a:p>
-            <a:pPr algn="ctr" indent="0" marL="0">
+            <a:pPr marL="0" indent="0" algn="ctr">
               <a:buNone/>
             </a:pPr>
             <a:r>
@@ -2480,7 +2240,7 @@
             <a:endParaRPr lang="en-US" sz="920" dirty="0"/>
           </a:p>
           <a:p>
-            <a:pPr algn="ctr" indent="0" marL="0">
+            <a:pPr marL="0" indent="0" algn="ctr">
               <a:buNone/>
             </a:pPr>
             <a:r>
@@ -2548,7 +2308,7 @@
           </a:bodyPr>
           <a:lstStyle/>
           <a:p>
-            <a:pPr algn="ctr" indent="0" marL="0">
+            <a:pPr marL="0" indent="0" algn="ctr">
               <a:buNone/>
             </a:pPr>
             <a:r>
@@ -2565,7 +2325,7 @@
             <a:endParaRPr lang="en-US" sz="950" dirty="0"/>
           </a:p>
           <a:p>
-            <a:pPr algn="ctr" indent="0" marL="0">
+            <a:pPr marL="0" indent="0" algn="ctr">
               <a:buNone/>
             </a:pPr>
             <a:r>
@@ -2633,7 +2393,7 @@
           </a:bodyPr>
           <a:lstStyle/>
           <a:p>
-            <a:pPr algn="ctr" indent="0" marL="0">
+            <a:pPr marL="0" indent="0" algn="ctr">
               <a:buNone/>
             </a:pPr>
             <a:r>
@@ -2650,7 +2410,7 @@
             <a:endParaRPr lang="en-US" sz="950" dirty="0"/>
           </a:p>
           <a:p>
-            <a:pPr algn="ctr" indent="0" marL="0">
+            <a:pPr marL="0" indent="0" algn="ctr">
               <a:buNone/>
             </a:pPr>
             <a:r>
@@ -2718,7 +2478,7 @@
           </a:bodyPr>
           <a:lstStyle/>
           <a:p>
-            <a:pPr algn="ctr" indent="0" marL="0">
+            <a:pPr marL="0" indent="0" algn="ctr">
               <a:buNone/>
             </a:pPr>
             <a:r>
@@ -2735,7 +2495,7 @@
             <a:endParaRPr lang="en-US" sz="950" dirty="0"/>
           </a:p>
           <a:p>
-            <a:pPr algn="ctr" indent="0" marL="0">
+            <a:pPr marL="0" indent="0" algn="ctr">
               <a:buNone/>
             </a:pPr>
             <a:r>
@@ -2923,7 +2683,7 @@
           </a:bodyPr>
           <a:lstStyle/>
           <a:p>
-            <a:pPr algn="ctr" indent="0" marL="0">
+            <a:pPr marL="0" indent="0" algn="ctr">
               <a:buNone/>
             </a:pPr>
             <a:r>
@@ -2940,7 +2700,7 @@
             <a:endParaRPr lang="en-US" sz="1100" dirty="0"/>
           </a:p>
           <a:p>
-            <a:pPr algn="ctr" indent="0" marL="0">
+            <a:pPr marL="0" indent="0" algn="ctr">
               <a:buNone/>
             </a:pPr>
             <a:r>
@@ -3008,7 +2768,7 @@
           </a:bodyPr>
           <a:lstStyle/>
           <a:p>
-            <a:pPr algn="ctr" indent="0" marL="0">
+            <a:pPr marL="0" indent="0" algn="ctr">
               <a:buNone/>
             </a:pPr>
             <a:r>
@@ -3025,7 +2785,7 @@
             <a:endParaRPr lang="en-US" sz="1100" dirty="0"/>
           </a:p>
           <a:p>
-            <a:pPr algn="ctr" indent="0" marL="0">
+            <a:pPr marL="0" indent="0" algn="ctr">
               <a:buNone/>
             </a:pPr>
             <a:r>
@@ -3093,7 +2853,7 @@
           </a:bodyPr>
           <a:lstStyle/>
           <a:p>
-            <a:pPr algn="ctr" indent="0" marL="0">
+            <a:pPr marL="0" indent="0" algn="ctr">
               <a:buNone/>
             </a:pPr>
             <a:r>
@@ -3110,7 +2870,7 @@
             <a:endParaRPr lang="en-US" sz="1100" dirty="0"/>
           </a:p>
           <a:p>
-            <a:pPr algn="ctr" indent="0" marL="0">
+            <a:pPr marL="0" indent="0" algn="ctr">
               <a:buNone/>
             </a:pPr>
             <a:r>
@@ -3178,7 +2938,7 @@
           </a:bodyPr>
           <a:lstStyle/>
           <a:p>
-            <a:pPr algn="ctr" indent="0" marL="0">
+            <a:pPr marL="0" indent="0" algn="ctr">
               <a:buNone/>
             </a:pPr>
             <a:r>
@@ -3195,7 +2955,7 @@
             <a:endParaRPr lang="en-US" sz="1020" dirty="0"/>
           </a:p>
           <a:p>
-            <a:pPr algn="ctr" indent="0" marL="0">
+            <a:pPr marL="0" indent="0" algn="ctr">
               <a:buNone/>
             </a:pPr>
             <a:r>
@@ -3294,7 +3054,7 @@
         <p:spPr>
           <a:xfrm>
             <a:off x="10469880" y="1965960"/>
-            <a:ext cx="-6126480" cy="914400"/>
+            <a:ext cx="0" cy="914400"/>
           </a:xfrm>
           <a:prstGeom prst="line">
             <a:avLst/>
@@ -3332,7 +3092,7 @@
           </a:bodyPr>
           <a:lstStyle/>
           <a:p>
-            <a:pPr algn="ctr" indent="0" marL="0">
+            <a:pPr marL="0" indent="0" algn="ctr">
               <a:buNone/>
             </a:pPr>
             <a:r>
@@ -3366,6 +3126,7 @@
         <a:solidFill>
           <a:srgbClr val="F8FAFC"/>
         </a:solidFill>
+        <a:effectLst/>
       </p:bgPr>
     </p:bg>
     <p:spTree>
@@ -3405,7 +3166,7 @@
           </a:bodyPr>
           <a:lstStyle/>
           <a:p>
-            <a:pPr indent="0" marL="0">
+            <a:pPr marL="0" indent="0">
               <a:buNone/>
             </a:pPr>
             <a:r>
@@ -3446,7 +3207,7 @@
           </a:bodyPr>
           <a:lstStyle/>
           <a:p>
-            <a:pPr indent="0" marL="0">
+            <a:pPr marL="0" indent="0">
               <a:buNone/>
             </a:pPr>
             <a:r>
@@ -3537,7 +3298,7 @@
           </a:bodyPr>
           <a:lstStyle/>
           <a:p>
-            <a:pPr algn="ctr" indent="0" marL="0">
+            <a:pPr marL="0" indent="0" algn="ctr">
               <a:buNone/>
             </a:pPr>
             <a:r>
@@ -3554,7 +3315,7 @@
             <a:endParaRPr lang="en-US" sz="1000" dirty="0"/>
           </a:p>
           <a:p>
-            <a:pPr algn="ctr" indent="0" marL="0">
+            <a:pPr marL="0" indent="0" algn="ctr">
               <a:buNone/>
             </a:pPr>
             <a:r>
@@ -3622,7 +3383,7 @@
           </a:bodyPr>
           <a:lstStyle/>
           <a:p>
-            <a:pPr algn="ctr" indent="0" marL="0">
+            <a:pPr marL="0" indent="0" algn="ctr">
               <a:buNone/>
             </a:pPr>
             <a:r>
@@ -3639,7 +3400,7 @@
             <a:endParaRPr lang="en-US" sz="1000" dirty="0"/>
           </a:p>
           <a:p>
-            <a:pPr algn="ctr" indent="0" marL="0">
+            <a:pPr marL="0" indent="0" algn="ctr">
               <a:buNone/>
             </a:pPr>
             <a:r>
@@ -3707,7 +3468,7 @@
           </a:bodyPr>
           <a:lstStyle/>
           <a:p>
-            <a:pPr algn="ctr" indent="0" marL="0">
+            <a:pPr marL="0" indent="0" algn="ctr">
               <a:buNone/>
             </a:pPr>
             <a:r>
@@ -3724,7 +3485,7 @@
             <a:endParaRPr lang="en-US" sz="1000" dirty="0"/>
           </a:p>
           <a:p>
-            <a:pPr algn="ctr" indent="0" marL="0">
+            <a:pPr marL="0" indent="0" algn="ctr">
               <a:buNone/>
             </a:pPr>
             <a:r>
@@ -3792,7 +3553,7 @@
           </a:bodyPr>
           <a:lstStyle/>
           <a:p>
-            <a:pPr algn="ctr" indent="0" marL="0">
+            <a:pPr marL="0" indent="0" algn="ctr">
               <a:buNone/>
             </a:pPr>
             <a:r>
@@ -3809,7 +3570,7 @@
             <a:endParaRPr lang="en-US" sz="1000" dirty="0"/>
           </a:p>
           <a:p>
-            <a:pPr algn="ctr" indent="0" marL="0">
+            <a:pPr marL="0" indent="0" algn="ctr">
               <a:buNone/>
             </a:pPr>
             <a:r>
@@ -3877,7 +3638,7 @@
           </a:bodyPr>
           <a:lstStyle/>
           <a:p>
-            <a:pPr algn="ctr" indent="0" marL="0">
+            <a:pPr marL="0" indent="0" algn="ctr">
               <a:buNone/>
             </a:pPr>
             <a:r>
@@ -4041,7 +3802,7 @@
           </a:bodyPr>
           <a:lstStyle/>
           <a:p>
-            <a:pPr algn="ctr" indent="0" marL="0">
+            <a:pPr marL="0" indent="0" algn="ctr">
               <a:buNone/>
             </a:pPr>
             <a:r>
@@ -4109,7 +3870,7 @@
           </a:bodyPr>
           <a:lstStyle/>
           <a:p>
-            <a:pPr algn="ctr" indent="0" marL="0">
+            <a:pPr marL="0" indent="0" algn="ctr">
               <a:buNone/>
             </a:pPr>
             <a:r>
@@ -4177,7 +3938,7 @@
           </a:bodyPr>
           <a:lstStyle/>
           <a:p>
-            <a:pPr algn="ctr" indent="0" marL="0">
+            <a:pPr marL="0" indent="0" algn="ctr">
               <a:buNone/>
             </a:pPr>
             <a:r>
@@ -4245,7 +4006,7 @@
           </a:bodyPr>
           <a:lstStyle/>
           <a:p>
-            <a:pPr algn="ctr" indent="0" marL="0">
+            <a:pPr marL="0" indent="0" algn="ctr">
               <a:buNone/>
             </a:pPr>
             <a:r>
@@ -4313,7 +4074,7 @@
           </a:bodyPr>
           <a:lstStyle/>
           <a:p>
-            <a:pPr algn="ctr" indent="0" marL="0">
+            <a:pPr marL="0" indent="0" algn="ctr">
               <a:buNone/>
             </a:pPr>
             <a:r>
@@ -4381,7 +4142,7 @@
           </a:bodyPr>
           <a:lstStyle/>
           <a:p>
-            <a:pPr algn="ctr" indent="0" marL="0">
+            <a:pPr marL="0" indent="0" algn="ctr">
               <a:buNone/>
             </a:pPr>
             <a:r>
@@ -4408,7 +4169,7 @@
         <p:spPr>
           <a:xfrm>
             <a:off x="2560320" y="3145536"/>
-            <a:ext cx="411480" cy="-548640"/>
+            <a:ext cx="411480" cy="0"/>
           </a:xfrm>
           <a:prstGeom prst="line">
             <a:avLst/>
@@ -4480,7 +4241,7 @@
         <p:spPr>
           <a:xfrm>
             <a:off x="4480560" y="3694176"/>
-            <a:ext cx="502920" cy="-548640"/>
+            <a:ext cx="502920" cy="0"/>
           </a:xfrm>
           <a:prstGeom prst="line">
             <a:avLst/>
@@ -4504,7 +4265,7 @@
         <p:spPr>
           <a:xfrm>
             <a:off x="6629400" y="3145536"/>
-            <a:ext cx="-5715000" cy="0"/>
+            <a:ext cx="0" cy="0"/>
           </a:xfrm>
           <a:prstGeom prst="line">
             <a:avLst/>
@@ -4590,7 +4351,7 @@
           </a:bodyPr>
           <a:lstStyle/>
           <a:p>
-            <a:pPr algn="ctr" indent="0" marL="0">
+            <a:pPr marL="0" indent="0" algn="ctr">
               <a:buNone/>
             </a:pPr>
             <a:r>
@@ -4624,6 +4385,7 @@
         <a:solidFill>
           <a:srgbClr val="F8FAFC"/>
         </a:solidFill>
+        <a:effectLst/>
       </p:bgPr>
     </p:bg>
     <p:spTree>
@@ -4663,7 +4425,7 @@
           </a:bodyPr>
           <a:lstStyle/>
           <a:p>
-            <a:pPr indent="0" marL="0">
+            <a:pPr marL="0" indent="0">
               <a:buNone/>
             </a:pPr>
             <a:r>
@@ -4704,7 +4466,7 @@
           </a:bodyPr>
           <a:lstStyle/>
           <a:p>
-            <a:pPr indent="0" marL="0">
+            <a:pPr marL="0" indent="0">
               <a:buNone/>
             </a:pPr>
             <a:r>
@@ -4768,7 +4530,7 @@
           </a:bodyPr>
           <a:lstStyle/>
           <a:p>
-            <a:pPr algn="l" indent="0" marL="0">
+            <a:pPr marL="0" indent="0" algn="l">
               <a:buNone/>
             </a:pPr>
             <a:r>
@@ -4836,7 +4598,7 @@
           </a:bodyPr>
           <a:lstStyle/>
           <a:p>
-            <a:pPr algn="ctr" indent="0" marL="0">
+            <a:pPr marL="0" indent="0" algn="ctr">
               <a:buNone/>
             </a:pPr>
             <a:r>
@@ -4853,7 +4615,7 @@
             <a:endParaRPr lang="en-US" sz="850" dirty="0"/>
           </a:p>
           <a:p>
-            <a:pPr algn="ctr" indent="0" marL="0">
+            <a:pPr marL="0" indent="0" algn="ctr">
               <a:buNone/>
             </a:pPr>
             <a:r>
@@ -4944,7 +4706,7 @@
           </a:bodyPr>
           <a:lstStyle/>
           <a:p>
-            <a:pPr algn="ctr" indent="0" marL="0">
+            <a:pPr marL="0" indent="0" algn="ctr">
               <a:buNone/>
             </a:pPr>
             <a:r>
@@ -4961,7 +4723,7 @@
             <a:endParaRPr lang="en-US" sz="850" dirty="0"/>
           </a:p>
           <a:p>
-            <a:pPr algn="ctr" indent="0" marL="0">
+            <a:pPr marL="0" indent="0" algn="ctr">
               <a:buNone/>
             </a:pPr>
             <a:r>
@@ -5052,7 +4814,7 @@
           </a:bodyPr>
           <a:lstStyle/>
           <a:p>
-            <a:pPr algn="ctr" indent="0" marL="0">
+            <a:pPr marL="0" indent="0" algn="ctr">
               <a:buNone/>
             </a:pPr>
             <a:r>
@@ -5143,7 +4905,7 @@
           </a:bodyPr>
           <a:lstStyle/>
           <a:p>
-            <a:pPr algn="ctr" indent="0" marL="0">
+            <a:pPr marL="0" indent="0" algn="ctr">
               <a:buNone/>
             </a:pPr>
             <a:r>
@@ -5160,7 +4922,7 @@
             <a:endParaRPr lang="en-US" sz="850" dirty="0"/>
           </a:p>
           <a:p>
-            <a:pPr algn="ctr" indent="0" marL="0">
+            <a:pPr marL="0" indent="0" algn="ctr">
               <a:buNone/>
             </a:pPr>
             <a:r>
@@ -5251,7 +5013,7 @@
           </a:bodyPr>
           <a:lstStyle/>
           <a:p>
-            <a:pPr algn="ctr" indent="0" marL="0">
+            <a:pPr marL="0" indent="0" algn="ctr">
               <a:buNone/>
             </a:pPr>
             <a:r>
@@ -5268,7 +5030,7 @@
             <a:endParaRPr lang="en-US" sz="850" dirty="0"/>
           </a:p>
           <a:p>
-            <a:pPr algn="ctr" indent="0" marL="0">
+            <a:pPr marL="0" indent="0" algn="ctr">
               <a:buNone/>
             </a:pPr>
             <a:r>
@@ -5359,7 +5121,7 @@
           </a:bodyPr>
           <a:lstStyle/>
           <a:p>
-            <a:pPr algn="ctr" indent="0" marL="0">
+            <a:pPr marL="0" indent="0" algn="ctr">
               <a:buNone/>
             </a:pPr>
             <a:r>
@@ -5376,7 +5138,7 @@
             <a:endParaRPr lang="en-US" sz="850" dirty="0"/>
           </a:p>
           <a:p>
-            <a:pPr algn="ctr" indent="0" marL="0">
+            <a:pPr marL="0" indent="0" algn="ctr">
               <a:buNone/>
             </a:pPr>
             <a:r>
@@ -5463,7 +5225,7 @@
           </a:bodyPr>
           <a:lstStyle/>
           <a:p>
-            <a:pPr algn="ctr" indent="0" marL="0">
+            <a:pPr marL="0" indent="0" algn="ctr">
               <a:buNone/>
             </a:pPr>
             <a:r>
@@ -5527,7 +5289,7 @@
           </a:bodyPr>
           <a:lstStyle/>
           <a:p>
-            <a:pPr algn="ctr" indent="0" marL="0">
+            <a:pPr marL="0" indent="0" algn="ctr">
               <a:buNone/>
             </a:pPr>
             <a:r>
@@ -5568,7 +5330,7 @@
           </a:bodyPr>
           <a:lstStyle/>
           <a:p>
-            <a:pPr algn="l" indent="0" marL="0">
+            <a:pPr marL="0" indent="0" algn="l">
               <a:buNone/>
             </a:pPr>
             <a:r>
@@ -5636,7 +5398,7 @@
           </a:bodyPr>
           <a:lstStyle/>
           <a:p>
-            <a:pPr algn="ctr" indent="0" marL="0">
+            <a:pPr marL="0" indent="0" algn="ctr">
               <a:buNone/>
             </a:pPr>
             <a:r>
@@ -5704,7 +5466,7 @@
           </a:bodyPr>
           <a:lstStyle/>
           <a:p>
-            <a:pPr algn="ctr" indent="0" marL="0">
+            <a:pPr marL="0" indent="0" algn="ctr">
               <a:buNone/>
             </a:pPr>
             <a:r>
@@ -5721,7 +5483,7 @@
             <a:endParaRPr lang="en-US" sz="900" dirty="0"/>
           </a:p>
           <a:p>
-            <a:pPr algn="ctr" indent="0" marL="0">
+            <a:pPr marL="0" indent="0" algn="ctr">
               <a:buNone/>
             </a:pPr>
             <a:r>
@@ -5789,7 +5551,7 @@
           </a:bodyPr>
           <a:lstStyle/>
           <a:p>
-            <a:pPr algn="ctr" indent="0" marL="0">
+            <a:pPr marL="0" indent="0" algn="ctr">
               <a:buNone/>
             </a:pPr>
             <a:r>
@@ -5806,7 +5568,7 @@
             <a:endParaRPr lang="en-US" sz="900" dirty="0"/>
           </a:p>
           <a:p>
-            <a:pPr algn="ctr" indent="0" marL="0">
+            <a:pPr marL="0" indent="0" algn="ctr">
               <a:buNone/>
             </a:pPr>
             <a:r>
@@ -5874,7 +5636,7 @@
           </a:bodyPr>
           <a:lstStyle/>
           <a:p>
-            <a:pPr algn="ctr" indent="0" marL="0">
+            <a:pPr marL="0" indent="0" algn="ctr">
               <a:buNone/>
             </a:pPr>
             <a:r>
@@ -5942,7 +5704,7 @@
           </a:bodyPr>
           <a:lstStyle/>
           <a:p>
-            <a:pPr algn="ctr" indent="0" marL="0">
+            <a:pPr marL="0" indent="0" algn="ctr">
               <a:buNone/>
             </a:pPr>
             <a:r>
@@ -6010,7 +5772,7 @@
           </a:bodyPr>
           <a:lstStyle/>
           <a:p>
-            <a:pPr algn="ctr" indent="0" marL="0">
+            <a:pPr marL="0" indent="0" algn="ctr">
               <a:buNone/>
             </a:pPr>
             <a:r>
@@ -6171,7 +5933,7 @@
           </a:bodyPr>
           <a:lstStyle/>
           <a:p>
-            <a:pPr algn="ctr" indent="0" marL="0">
+            <a:pPr marL="0" indent="0" algn="ctr">
               <a:buNone/>
             </a:pPr>
             <a:r>
@@ -6205,6 +5967,7 @@
         <a:solidFill>
           <a:srgbClr val="F8FAFC"/>
         </a:solidFill>
+        <a:effectLst/>
       </p:bgPr>
     </p:bg>
     <p:spTree>
@@ -6244,7 +6007,7 @@
           </a:bodyPr>
           <a:lstStyle/>
           <a:p>
-            <a:pPr indent="0" marL="0">
+            <a:pPr marL="0" indent="0">
               <a:buNone/>
             </a:pPr>
             <a:r>
@@ -6285,7 +6048,7 @@
           </a:bodyPr>
           <a:lstStyle/>
           <a:p>
-            <a:pPr indent="0" marL="0">
+            <a:pPr marL="0" indent="0">
               <a:buNone/>
             </a:pPr>
             <a:r>
@@ -6376,7 +6139,7 @@
           </a:bodyPr>
           <a:lstStyle/>
           <a:p>
-            <a:pPr algn="l" indent="0" marL="0">
+            <a:pPr marL="0" indent="0" algn="l">
               <a:buNone/>
             </a:pPr>
             <a:r>
@@ -6444,7 +6207,7 @@
           </a:bodyPr>
           <a:lstStyle/>
           <a:p>
-            <a:pPr algn="l" indent="0" marL="0">
+            <a:pPr marL="0" indent="0" algn="l">
               <a:buNone/>
             </a:pPr>
             <a:r>
@@ -6512,7 +6275,7 @@
           </a:bodyPr>
           <a:lstStyle/>
           <a:p>
-            <a:pPr algn="l" indent="0" marL="0">
+            <a:pPr marL="0" indent="0" algn="l">
               <a:buNone/>
             </a:pPr>
             <a:r>
@@ -6580,7 +6343,7 @@
           </a:bodyPr>
           <a:lstStyle/>
           <a:p>
-            <a:pPr algn="l" indent="0" marL="0">
+            <a:pPr marL="0" indent="0" algn="l">
               <a:buNone/>
             </a:pPr>
             <a:r>
@@ -6648,7 +6411,7 @@
           </a:bodyPr>
           <a:lstStyle/>
           <a:p>
-            <a:pPr algn="l" indent="0" marL="0">
+            <a:pPr marL="0" indent="0" algn="l">
               <a:buNone/>
             </a:pPr>
             <a:r>
@@ -6716,7 +6479,7 @@
           </a:bodyPr>
           <a:lstStyle/>
           <a:p>
-            <a:pPr algn="l" indent="0" marL="0">
+            <a:pPr marL="0" indent="0" algn="l">
               <a:buNone/>
             </a:pPr>
             <a:r>
@@ -6784,7 +6547,7 @@
           </a:bodyPr>
           <a:lstStyle/>
           <a:p>
-            <a:pPr algn="l" indent="0" marL="0">
+            <a:pPr marL="0" indent="0" algn="l">
               <a:buNone/>
             </a:pPr>
             <a:r>
@@ -6852,7 +6615,7 @@
           </a:bodyPr>
           <a:lstStyle/>
           <a:p>
-            <a:pPr algn="l" indent="0" marL="0">
+            <a:pPr marL="0" indent="0" algn="l">
               <a:buNone/>
             </a:pPr>
             <a:r>
@@ -6920,7 +6683,7 @@
           </a:bodyPr>
           <a:lstStyle/>
           <a:p>
-            <a:pPr algn="l" indent="0" marL="0">
+            <a:pPr marL="0" indent="0" algn="l">
               <a:buNone/>
             </a:pPr>
             <a:r>
@@ -6988,7 +6751,7 @@
           </a:bodyPr>
           <a:lstStyle/>
           <a:p>
-            <a:pPr algn="l" indent="0" marL="0">
+            <a:pPr marL="0" indent="0" algn="l">
               <a:buNone/>
             </a:pPr>
             <a:r>
@@ -7056,7 +6819,7 @@
           </a:bodyPr>
           <a:lstStyle/>
           <a:p>
-            <a:pPr algn="l" indent="0" marL="0">
+            <a:pPr marL="0" indent="0" algn="l">
               <a:buNone/>
             </a:pPr>
             <a:r>
@@ -7124,7 +6887,7 @@
           </a:bodyPr>
           <a:lstStyle/>
           <a:p>
-            <a:pPr algn="l" indent="0" marL="0">
+            <a:pPr marL="0" indent="0" algn="l">
               <a:buNone/>
             </a:pPr>
             <a:r>
@@ -7192,7 +6955,7 @@
           </a:bodyPr>
           <a:lstStyle/>
           <a:p>
-            <a:pPr algn="l" indent="0" marL="0">
+            <a:pPr marL="0" indent="0" algn="l">
               <a:buNone/>
             </a:pPr>
             <a:r>
@@ -7260,7 +7023,7 @@
           </a:bodyPr>
           <a:lstStyle/>
           <a:p>
-            <a:pPr algn="l" indent="0" marL="0">
+            <a:pPr marL="0" indent="0" algn="l">
               <a:buNone/>
             </a:pPr>
             <a:r>
@@ -7328,7 +7091,7 @@
           </a:bodyPr>
           <a:lstStyle/>
           <a:p>
-            <a:pPr algn="l" indent="0" marL="0">
+            <a:pPr marL="0" indent="0" algn="l">
               <a:buNone/>
             </a:pPr>
             <a:r>
@@ -7396,7 +7159,7 @@
           </a:bodyPr>
           <a:lstStyle/>
           <a:p>
-            <a:pPr algn="l" indent="0" marL="0">
+            <a:pPr marL="0" indent="0" algn="l">
               <a:buNone/>
             </a:pPr>
             <a:r>
@@ -7464,7 +7227,7 @@
           </a:bodyPr>
           <a:lstStyle/>
           <a:p>
-            <a:pPr algn="l" indent="0" marL="0">
+            <a:pPr marL="0" indent="0" algn="l">
               <a:buNone/>
             </a:pPr>
             <a:r>
@@ -7532,7 +7295,7 @@
           </a:bodyPr>
           <a:lstStyle/>
           <a:p>
-            <a:pPr algn="l" indent="0" marL="0">
+            <a:pPr marL="0" indent="0" algn="l">
               <a:buNone/>
             </a:pPr>
             <a:r>
@@ -7600,7 +7363,7 @@
           </a:bodyPr>
           <a:lstStyle/>
           <a:p>
-            <a:pPr algn="l" indent="0" marL="0">
+            <a:pPr marL="0" indent="0" algn="l">
               <a:buNone/>
             </a:pPr>
             <a:r>
@@ -7668,7 +7431,7 @@
           </a:bodyPr>
           <a:lstStyle/>
           <a:p>
-            <a:pPr algn="l" indent="0" marL="0">
+            <a:pPr marL="0" indent="0" algn="l">
               <a:buNone/>
             </a:pPr>
             <a:r>
@@ -7736,7 +7499,7 @@
           </a:bodyPr>
           <a:lstStyle/>
           <a:p>
-            <a:pPr algn="l" indent="0" marL="0">
+            <a:pPr marL="0" indent="0" algn="l">
               <a:buNone/>
             </a:pPr>
             <a:r>
@@ -7804,7 +7567,7 @@
           </a:bodyPr>
           <a:lstStyle/>
           <a:p>
-            <a:pPr algn="l" indent="0" marL="0">
+            <a:pPr marL="0" indent="0" algn="l">
               <a:buNone/>
             </a:pPr>
             <a:r>
@@ -7872,7 +7635,7 @@
           </a:bodyPr>
           <a:lstStyle/>
           <a:p>
-            <a:pPr algn="l" indent="0" marL="0">
+            <a:pPr marL="0" indent="0" algn="l">
               <a:buNone/>
             </a:pPr>
             <a:r>
@@ -7940,7 +7703,7 @@
           </a:bodyPr>
           <a:lstStyle/>
           <a:p>
-            <a:pPr algn="l" indent="0" marL="0">
+            <a:pPr marL="0" indent="0" algn="l">
               <a:buNone/>
             </a:pPr>
             <a:r>
@@ -8008,7 +7771,7 @@
           </a:bodyPr>
           <a:lstStyle/>
           <a:p>
-            <a:pPr algn="l" indent="0" marL="0">
+            <a:pPr marL="0" indent="0" algn="l">
               <a:buNone/>
             </a:pPr>
             <a:r>
@@ -8076,7 +7839,7 @@
           </a:bodyPr>
           <a:lstStyle/>
           <a:p>
-            <a:pPr algn="l" indent="0" marL="0">
+            <a:pPr marL="0" indent="0" algn="l">
               <a:buNone/>
             </a:pPr>
             <a:r>
@@ -8144,7 +7907,7 @@
           </a:bodyPr>
           <a:lstStyle/>
           <a:p>
-            <a:pPr algn="l" indent="0" marL="0">
+            <a:pPr marL="0" indent="0" algn="l">
               <a:buNone/>
             </a:pPr>
             <a:r>
@@ -8212,7 +7975,7 @@
           </a:bodyPr>
           <a:lstStyle/>
           <a:p>
-            <a:pPr algn="l" indent="0" marL="0">
+            <a:pPr marL="0" indent="0" algn="l">
               <a:buNone/>
             </a:pPr>
             <a:r>
@@ -8280,7 +8043,7 @@
           </a:bodyPr>
           <a:lstStyle/>
           <a:p>
-            <a:pPr algn="ctr" indent="0" marL="0">
+            <a:pPr marL="0" indent="0" algn="ctr">
               <a:buNone/>
             </a:pPr>
             <a:r>
@@ -8297,7 +8060,7 @@
             <a:endParaRPr lang="en-US" sz="1100" dirty="0"/>
           </a:p>
           <a:p>
-            <a:pPr algn="ctr" indent="0" marL="0">
+            <a:pPr marL="0" indent="0" algn="ctr">
               <a:buNone/>
             </a:pPr>
             <a:r>
@@ -8365,7 +8128,7 @@
           </a:bodyPr>
           <a:lstStyle/>
           <a:p>
-            <a:pPr algn="ctr" indent="0" marL="0">
+            <a:pPr marL="0" indent="0" algn="ctr">
               <a:buNone/>
             </a:pPr>
             <a:r>
@@ -8382,7 +8145,7 @@
             <a:endParaRPr lang="en-US" sz="1100" dirty="0"/>
           </a:p>
           <a:p>
-            <a:pPr algn="ctr" indent="0" marL="0">
+            <a:pPr marL="0" indent="0" algn="ctr">
               <a:buNone/>
             </a:pPr>
             <a:r>
@@ -8450,7 +8213,7 @@
           </a:bodyPr>
           <a:lstStyle/>
           <a:p>
-            <a:pPr algn="ctr" indent="0" marL="0">
+            <a:pPr marL="0" indent="0" algn="ctr">
               <a:buNone/>
             </a:pPr>
             <a:r>
@@ -8467,7 +8230,7 @@
             <a:endParaRPr lang="en-US" sz="1100" dirty="0"/>
           </a:p>
           <a:p>
-            <a:pPr algn="ctr" indent="0" marL="0">
+            <a:pPr marL="0" indent="0" algn="ctr">
               <a:buNone/>
             </a:pPr>
             <a:r>
@@ -8501,6 +8264,7 @@
         <a:solidFill>
           <a:srgbClr val="F8FAFC"/>
         </a:solidFill>
+        <a:effectLst/>
       </p:bgPr>
     </p:bg>
     <p:spTree>
@@ -8540,7 +8304,7 @@
           </a:bodyPr>
           <a:lstStyle/>
           <a:p>
-            <a:pPr indent="0" marL="0">
+            <a:pPr marL="0" indent="0">
               <a:buNone/>
             </a:pPr>
             <a:r>
@@ -8581,7 +8345,7 @@
           </a:bodyPr>
           <a:lstStyle/>
           <a:p>
-            <a:pPr indent="0" marL="0">
+            <a:pPr marL="0" indent="0">
               <a:buNone/>
             </a:pPr>
             <a:r>
@@ -8672,7 +8436,7 @@
           </a:bodyPr>
           <a:lstStyle/>
           <a:p>
-            <a:pPr algn="ctr" indent="0" marL="0">
+            <a:pPr marL="0" indent="0" algn="ctr">
               <a:buNone/>
             </a:pPr>
             <a:r>
@@ -8740,7 +8504,7 @@
           </a:bodyPr>
           <a:lstStyle/>
           <a:p>
-            <a:pPr algn="l" indent="0" marL="0">
+            <a:pPr marL="0" indent="0" algn="l">
               <a:buNone/>
             </a:pPr>
             <a:r>
@@ -8808,7 +8572,7 @@
           </a:bodyPr>
           <a:lstStyle/>
           <a:p>
-            <a:pPr algn="ctr" indent="0" marL="0">
+            <a:pPr marL="0" indent="0" algn="ctr">
               <a:buNone/>
             </a:pPr>
             <a:r>
@@ -8876,7 +8640,7 @@
           </a:bodyPr>
           <a:lstStyle/>
           <a:p>
-            <a:pPr algn="ctr" indent="0" marL="0">
+            <a:pPr marL="0" indent="0" algn="ctr">
               <a:buNone/>
             </a:pPr>
             <a:r>
@@ -8944,7 +8708,7 @@
           </a:bodyPr>
           <a:lstStyle/>
           <a:p>
-            <a:pPr algn="l" indent="0" marL="0">
+            <a:pPr marL="0" indent="0" algn="l">
               <a:buNone/>
             </a:pPr>
             <a:r>
@@ -9012,7 +8776,7 @@
           </a:bodyPr>
           <a:lstStyle/>
           <a:p>
-            <a:pPr algn="ctr" indent="0" marL="0">
+            <a:pPr marL="0" indent="0" algn="ctr">
               <a:buNone/>
             </a:pPr>
             <a:r>
@@ -9080,7 +8844,7 @@
           </a:bodyPr>
           <a:lstStyle/>
           <a:p>
-            <a:pPr algn="ctr" indent="0" marL="0">
+            <a:pPr marL="0" indent="0" algn="ctr">
               <a:buNone/>
             </a:pPr>
             <a:r>
@@ -9148,7 +8912,7 @@
           </a:bodyPr>
           <a:lstStyle/>
           <a:p>
-            <a:pPr algn="l" indent="0" marL="0">
+            <a:pPr marL="0" indent="0" algn="l">
               <a:buNone/>
             </a:pPr>
             <a:r>
@@ -9216,7 +8980,7 @@
           </a:bodyPr>
           <a:lstStyle/>
           <a:p>
-            <a:pPr algn="ctr" indent="0" marL="0">
+            <a:pPr marL="0" indent="0" algn="ctr">
               <a:buNone/>
             </a:pPr>
             <a:r>
@@ -9284,7 +9048,7 @@
           </a:bodyPr>
           <a:lstStyle/>
           <a:p>
-            <a:pPr algn="ctr" indent="0" marL="0">
+            <a:pPr marL="0" indent="0" algn="ctr">
               <a:buNone/>
             </a:pPr>
             <a:r>
@@ -9352,7 +9116,7 @@
           </a:bodyPr>
           <a:lstStyle/>
           <a:p>
-            <a:pPr algn="l" indent="0" marL="0">
+            <a:pPr marL="0" indent="0" algn="l">
               <a:buNone/>
             </a:pPr>
             <a:r>
@@ -9420,7 +9184,7 @@
           </a:bodyPr>
           <a:lstStyle/>
           <a:p>
-            <a:pPr algn="ctr" indent="0" marL="0">
+            <a:pPr marL="0" indent="0" algn="ctr">
               <a:buNone/>
             </a:pPr>
             <a:r>
@@ -9488,7 +9252,7 @@
           </a:bodyPr>
           <a:lstStyle/>
           <a:p>
-            <a:pPr algn="ctr" indent="0" marL="0">
+            <a:pPr marL="0" indent="0" algn="ctr">
               <a:buNone/>
             </a:pPr>
             <a:r>
@@ -9556,7 +9320,7 @@
           </a:bodyPr>
           <a:lstStyle/>
           <a:p>
-            <a:pPr algn="l" indent="0" marL="0">
+            <a:pPr marL="0" indent="0" algn="l">
               <a:buNone/>
             </a:pPr>
             <a:r>
@@ -9624,7 +9388,7 @@
           </a:bodyPr>
           <a:lstStyle/>
           <a:p>
-            <a:pPr algn="ctr" indent="0" marL="0">
+            <a:pPr marL="0" indent="0" algn="ctr">
               <a:buNone/>
             </a:pPr>
             <a:r>
@@ -9692,7 +9456,7 @@
           </a:bodyPr>
           <a:lstStyle/>
           <a:p>
-            <a:pPr algn="ctr" indent="0" marL="0">
+            <a:pPr marL="0" indent="0" algn="ctr">
               <a:buNone/>
             </a:pPr>
             <a:r>
@@ -9760,7 +9524,7 @@
           </a:bodyPr>
           <a:lstStyle/>
           <a:p>
-            <a:pPr algn="l" indent="0" marL="0">
+            <a:pPr marL="0" indent="0" algn="l">
               <a:buNone/>
             </a:pPr>
             <a:r>
@@ -9828,7 +9592,7 @@
           </a:bodyPr>
           <a:lstStyle/>
           <a:p>
-            <a:pPr algn="ctr" indent="0" marL="0">
+            <a:pPr marL="0" indent="0" algn="ctr">
               <a:buNone/>
             </a:pPr>
             <a:r>
@@ -9896,7 +9660,7 @@
           </a:bodyPr>
           <a:lstStyle/>
           <a:p>
-            <a:pPr algn="ctr" indent="0" marL="0">
+            <a:pPr marL="0" indent="0" algn="ctr">
               <a:buNone/>
             </a:pPr>
             <a:r>
@@ -9913,7 +9677,7 @@
             <a:endParaRPr lang="en-US" sz="1300" dirty="0"/>
           </a:p>
           <a:p>
-            <a:pPr algn="ctr" indent="0" marL="0">
+            <a:pPr marL="0" indent="0" algn="ctr">
               <a:buNone/>
             </a:pPr>
             <a:r>
@@ -9981,7 +9745,7 @@
           </a:bodyPr>
           <a:lstStyle/>
           <a:p>
-            <a:pPr algn="ctr" indent="0" marL="0">
+            <a:pPr marL="0" indent="0" algn="ctr">
               <a:buNone/>
             </a:pPr>
             <a:r>
@@ -9998,7 +9762,7 @@
             <a:endParaRPr lang="en-US" sz="1250" dirty="0"/>
           </a:p>
           <a:p>
-            <a:pPr algn="ctr" indent="0" marL="0">
+            <a:pPr marL="0" indent="0" algn="ctr">
               <a:buNone/>
             </a:pPr>
             <a:r>
@@ -10066,7 +9830,7 @@
           </a:bodyPr>
           <a:lstStyle/>
           <a:p>
-            <a:pPr algn="ctr" indent="0" marL="0">
+            <a:pPr marL="0" indent="0" algn="ctr">
               <a:buNone/>
             </a:pPr>
             <a:r>
@@ -10083,7 +9847,7 @@
             <a:endParaRPr lang="en-US" sz="1050" dirty="0"/>
           </a:p>
           <a:p>
-            <a:pPr algn="ctr" indent="0" marL="0">
+            <a:pPr marL="0" indent="0" algn="ctr">
               <a:buNone/>
             </a:pPr>
             <a:r>
@@ -10124,7 +9888,7 @@
           </a:bodyPr>
           <a:lstStyle/>
           <a:p>
-            <a:pPr algn="ctr" indent="0" marL="0">
+            <a:pPr marL="0" indent="0" algn="ctr">
               <a:buNone/>
             </a:pPr>
             <a:r>
@@ -10158,6 +9922,7 @@
         <a:solidFill>
           <a:srgbClr val="F8FAFC"/>
         </a:solidFill>
+        <a:effectLst/>
       </p:bgPr>
     </p:bg>
     <p:spTree>
@@ -10197,7 +9962,7 @@
           </a:bodyPr>
           <a:lstStyle/>
           <a:p>
-            <a:pPr indent="0" marL="0">
+            <a:pPr marL="0" indent="0">
               <a:buNone/>
             </a:pPr>
             <a:r>
@@ -10238,7 +10003,7 @@
           </a:bodyPr>
           <a:lstStyle/>
           <a:p>
-            <a:pPr indent="0" marL="0">
+            <a:pPr marL="0" indent="0">
               <a:buNone/>
             </a:pPr>
             <a:r>
@@ -10329,7 +10094,7 @@
           </a:bodyPr>
           <a:lstStyle/>
           <a:p>
-            <a:pPr algn="ctr" indent="0" marL="0">
+            <a:pPr marL="0" indent="0" algn="ctr">
               <a:buNone/>
             </a:pPr>
             <a:r>
@@ -10346,7 +10111,7 @@
             <a:endParaRPr lang="en-US" sz="1300" dirty="0"/>
           </a:p>
           <a:p>
-            <a:pPr algn="ctr" indent="0" marL="0">
+            <a:pPr marL="0" indent="0" algn="ctr">
               <a:buNone/>
             </a:pPr>
             <a:r>
@@ -10414,7 +10179,7 @@
           </a:bodyPr>
           <a:lstStyle/>
           <a:p>
-            <a:pPr algn="ctr" indent="0" marL="0">
+            <a:pPr marL="0" indent="0" algn="ctr">
               <a:buNone/>
             </a:pPr>
             <a:r>
@@ -10431,7 +10196,7 @@
             <a:endParaRPr lang="en-US" sz="1300" dirty="0"/>
           </a:p>
           <a:p>
-            <a:pPr algn="ctr" indent="0" marL="0">
+            <a:pPr marL="0" indent="0" algn="ctr">
               <a:buNone/>
             </a:pPr>
             <a:r>
@@ -10499,7 +10264,7 @@
           </a:bodyPr>
           <a:lstStyle/>
           <a:p>
-            <a:pPr algn="ctr" indent="0" marL="0">
+            <a:pPr marL="0" indent="0" algn="ctr">
               <a:buNone/>
             </a:pPr>
             <a:r>
@@ -10516,7 +10281,7 @@
             <a:endParaRPr lang="en-US" sz="1300" dirty="0"/>
           </a:p>
           <a:p>
-            <a:pPr algn="ctr" indent="0" marL="0">
+            <a:pPr marL="0" indent="0" algn="ctr">
               <a:buNone/>
             </a:pPr>
             <a:r>
@@ -10584,7 +10349,7 @@
           </a:bodyPr>
           <a:lstStyle/>
           <a:p>
-            <a:pPr algn="l" indent="0" marL="0">
+            <a:pPr marL="0" indent="0" algn="l">
               <a:buNone/>
             </a:pPr>
             <a:r>
@@ -10652,7 +10417,7 @@
           </a:bodyPr>
           <a:lstStyle/>
           <a:p>
-            <a:pPr algn="l" indent="0" marL="0">
+            <a:pPr marL="0" indent="0" algn="l">
               <a:buNone/>
             </a:pPr>
             <a:r>
@@ -10720,7 +10485,7 @@
           </a:bodyPr>
           <a:lstStyle/>
           <a:p>
-            <a:pPr algn="l" indent="0" marL="0">
+            <a:pPr marL="0" indent="0" algn="l">
               <a:buNone/>
             </a:pPr>
             <a:r>
@@ -10788,7 +10553,7 @@
           </a:bodyPr>
           <a:lstStyle/>
           <a:p>
-            <a:pPr algn="l" indent="0" marL="0">
+            <a:pPr marL="0" indent="0" algn="l">
               <a:buNone/>
             </a:pPr>
             <a:r>
@@ -10856,7 +10621,7 @@
           </a:bodyPr>
           <a:lstStyle/>
           <a:p>
-            <a:pPr algn="l" indent="0" marL="0">
+            <a:pPr marL="0" indent="0" algn="l">
               <a:buNone/>
             </a:pPr>
             <a:r>
@@ -10924,7 +10689,7 @@
           </a:bodyPr>
           <a:lstStyle/>
           <a:p>
-            <a:pPr algn="l" indent="0" marL="0">
+            <a:pPr marL="0" indent="0" algn="l">
               <a:buNone/>
             </a:pPr>
             <a:r>
@@ -10992,7 +10757,7 @@
           </a:bodyPr>
           <a:lstStyle/>
           <a:p>
-            <a:pPr algn="l" indent="0" marL="0">
+            <a:pPr marL="0" indent="0" algn="l">
               <a:buNone/>
             </a:pPr>
             <a:r>
@@ -11060,7 +10825,7 @@
           </a:bodyPr>
           <a:lstStyle/>
           <a:p>
-            <a:pPr algn="l" indent="0" marL="0">
+            <a:pPr marL="0" indent="0" algn="l">
               <a:buNone/>
             </a:pPr>
             <a:r>
@@ -11128,7 +10893,7 @@
           </a:bodyPr>
           <a:lstStyle/>
           <a:p>
-            <a:pPr algn="l" indent="0" marL="0">
+            <a:pPr marL="0" indent="0" algn="l">
               <a:buNone/>
             </a:pPr>
             <a:r>
@@ -11196,7 +10961,7 @@
           </a:bodyPr>
           <a:lstStyle/>
           <a:p>
-            <a:pPr algn="l" indent="0" marL="0">
+            <a:pPr marL="0" indent="0" algn="l">
               <a:buNone/>
             </a:pPr>
             <a:r>
@@ -11264,7 +11029,7 @@
           </a:bodyPr>
           <a:lstStyle/>
           <a:p>
-            <a:pPr algn="l" indent="0" marL="0">
+            <a:pPr marL="0" indent="0" algn="l">
               <a:buNone/>
             </a:pPr>
             <a:r>
@@ -11332,7 +11097,7 @@
           </a:bodyPr>
           <a:lstStyle/>
           <a:p>
-            <a:pPr algn="l" indent="0" marL="0">
+            <a:pPr marL="0" indent="0" algn="l">
               <a:buNone/>
             </a:pPr>
             <a:r>
@@ -11400,7 +11165,7 @@
           </a:bodyPr>
           <a:lstStyle/>
           <a:p>
-            <a:pPr algn="l" indent="0" marL="0">
+            <a:pPr marL="0" indent="0" algn="l">
               <a:buNone/>
             </a:pPr>
             <a:r>
@@ -11468,7 +11233,7 @@
           </a:bodyPr>
           <a:lstStyle/>
           <a:p>
-            <a:pPr algn="l" indent="0" marL="0">
+            <a:pPr marL="0" indent="0" algn="l">
               <a:buNone/>
             </a:pPr>
             <a:r>
@@ -11536,7 +11301,7 @@
           </a:bodyPr>
           <a:lstStyle/>
           <a:p>
-            <a:pPr algn="l" indent="0" marL="0">
+            <a:pPr marL="0" indent="0" algn="l">
               <a:buNone/>
             </a:pPr>
             <a:r>
@@ -11604,7 +11369,7 @@
           </a:bodyPr>
           <a:lstStyle/>
           <a:p>
-            <a:pPr algn="l" indent="0" marL="0">
+            <a:pPr marL="0" indent="0" algn="l">
               <a:buNone/>
             </a:pPr>
             <a:r>
@@ -11672,7 +11437,7 @@
           </a:bodyPr>
           <a:lstStyle/>
           <a:p>
-            <a:pPr algn="l" indent="0" marL="0">
+            <a:pPr marL="0" indent="0" algn="l">
               <a:buNone/>
             </a:pPr>
             <a:r>
@@ -11740,7 +11505,7 @@
           </a:bodyPr>
           <a:lstStyle/>
           <a:p>
-            <a:pPr algn="l" indent="0" marL="0">
+            <a:pPr marL="0" indent="0" algn="l">
               <a:buNone/>
             </a:pPr>
             <a:r>
@@ -11808,7 +11573,7 @@
           </a:bodyPr>
           <a:lstStyle/>
           <a:p>
-            <a:pPr algn="l" indent="0" marL="0">
+            <a:pPr marL="0" indent="0" algn="l">
               <a:buNone/>
             </a:pPr>
             <a:r>
@@ -11876,7 +11641,7 @@
           </a:bodyPr>
           <a:lstStyle/>
           <a:p>
-            <a:pPr algn="l" indent="0" marL="0">
+            <a:pPr marL="0" indent="0" algn="l">
               <a:buNone/>
             </a:pPr>
             <a:r>
@@ -11917,7 +11682,7 @@
           </a:bodyPr>
           <a:lstStyle/>
           <a:p>
-            <a:pPr algn="ctr" indent="0" marL="0">
+            <a:pPr marL="0" indent="0" algn="ctr">
               <a:buNone/>
             </a:pPr>
             <a:r>
@@ -12236,4 +12001,299 @@
     </a:ext>
   </a:extLst>
 </a:theme>
+</file>
+
+<file path=ppt/theme/theme2.xml><?xml version="1.0" encoding="utf-8"?>
+<a:theme xmlns:a="http://schemas.openxmlformats.org/drawingml/2006/main" name="Office 테마">
+  <a:themeElements>
+    <a:clrScheme name="Office">
+      <a:dk1>
+        <a:sysClr val="windowText" lastClr="000000"/>
+      </a:dk1>
+      <a:lt1>
+        <a:sysClr val="window" lastClr="FFFFFF"/>
+      </a:lt1>
+      <a:dk2>
+        <a:srgbClr val="44546A"/>
+      </a:dk2>
+      <a:lt2>
+        <a:srgbClr val="E7E6E6"/>
+      </a:lt2>
+      <a:accent1>
+        <a:srgbClr val="4472C4"/>
+      </a:accent1>
+      <a:accent2>
+        <a:srgbClr val="ED7D31"/>
+      </a:accent2>
+      <a:accent3>
+        <a:srgbClr val="A5A5A5"/>
+      </a:accent3>
+      <a:accent4>
+        <a:srgbClr val="FFC000"/>
+      </a:accent4>
+      <a:accent5>
+        <a:srgbClr val="5B9BD5"/>
+      </a:accent5>
+      <a:accent6>
+        <a:srgbClr val="70AD47"/>
+      </a:accent6>
+      <a:hlink>
+        <a:srgbClr val="0563C1"/>
+      </a:hlink>
+      <a:folHlink>
+        <a:srgbClr val="954F72"/>
+      </a:folHlink>
+    </a:clrScheme>
+    <a:fontScheme name="Office">
+      <a:majorFont>
+        <a:latin typeface="맑은 고딕" panose="020F0302020204030204"/>
+        <a:ea typeface=""/>
+        <a:cs typeface=""/>
+        <a:font script="Jpan" typeface="游ゴシック Light"/>
+        <a:font script="Hang" typeface="맑은 고딕"/>
+        <a:font script="Hans" typeface="等线 Light"/>
+        <a:font script="Hant" typeface="新細明體"/>
+        <a:font script="Arab" typeface="Times New Roman"/>
+        <a:font script="Hebr" typeface="Times New Roman"/>
+        <a:font script="Thai" typeface="Angsana New"/>
+        <a:font script="Ethi" typeface="Nyala"/>
+        <a:font script="Beng" typeface="Vrinda"/>
+        <a:font script="Gujr" typeface="Shruti"/>
+        <a:font script="Khmr" typeface="MoolBoran"/>
+        <a:font script="Knda" typeface="Tunga"/>
+        <a:font script="Guru" typeface="Raavi"/>
+        <a:font script="Cans" typeface="Euphemia"/>
+        <a:font script="Cher" typeface="Plantagenet Cherokee"/>
+        <a:font script="Yiii" typeface="Microsoft Yi Baiti"/>
+        <a:font script="Tibt" typeface="Microsoft Himalaya"/>
+        <a:font script="Thaa" typeface="MV Boli"/>
+        <a:font script="Deva" typeface="Mangal"/>
+        <a:font script="Telu" typeface="Gautami"/>
+        <a:font script="Taml" typeface="Latha"/>
+        <a:font script="Syrc" typeface="Estrangelo Edessa"/>
+        <a:font script="Orya" typeface="Kalinga"/>
+        <a:font script="Mlym" typeface="Kartika"/>
+        <a:font script="Laoo" typeface="DokChampa"/>
+        <a:font script="Sinh" typeface="Iskoola Pota"/>
+        <a:font script="Mong" typeface="Mongolian Baiti"/>
+        <a:font script="Viet" typeface="Times New Roman"/>
+        <a:font script="Uigh" typeface="Microsoft Uighur"/>
+        <a:font script="Geor" typeface="Sylfaen"/>
+        <a:font script="Armn" typeface="Arial"/>
+        <a:font script="Bugi" typeface="Leelawadee UI"/>
+        <a:font script="Bopo" typeface="Microsoft JhengHei"/>
+        <a:font script="Java" typeface="Javanese Text"/>
+        <a:font script="Lisu" typeface="Segoe UI"/>
+        <a:font script="Mymr" typeface="Myanmar Text"/>
+        <a:font script="Nkoo" typeface="Ebrima"/>
+        <a:font script="Olck" typeface="Nirmala UI"/>
+        <a:font script="Osma" typeface="Ebrima"/>
+        <a:font script="Phag" typeface="Phagspa"/>
+        <a:font script="Syrn" typeface="Estrangelo Edessa"/>
+        <a:font script="Syrj" typeface="Estrangelo Edessa"/>
+        <a:font script="Syre" typeface="Estrangelo Edessa"/>
+        <a:font script="Sora" typeface="Nirmala UI"/>
+        <a:font script="Tale" typeface="Microsoft Tai Le"/>
+        <a:font script="Talu" typeface="Microsoft New Tai Lue"/>
+        <a:font script="Tfng" typeface="Ebrima"/>
+      </a:majorFont>
+      <a:minorFont>
+        <a:latin typeface="맑은 고딕" panose="020F0502020204030204"/>
+        <a:ea typeface=""/>
+        <a:cs typeface=""/>
+        <a:font script="Jpan" typeface="游ゴシック"/>
+        <a:font script="Hang" typeface="맑은 고딕"/>
+        <a:font script="Hans" typeface="等线"/>
+        <a:font script="Hant" typeface="新細明體"/>
+        <a:font script="Arab" typeface="Arial"/>
+        <a:font script="Hebr" typeface="Arial"/>
+        <a:font script="Thai" typeface="Cordia New"/>
+        <a:font script="Ethi" typeface="Nyala"/>
+        <a:font script="Beng" typeface="Vrinda"/>
+        <a:font script="Gujr" typeface="Shruti"/>
+        <a:font script="Khmr" typeface="DaunPenh"/>
+        <a:font script="Knda" typeface="Tunga"/>
+        <a:font script="Guru" typeface="Raavi"/>
+        <a:font script="Cans" typeface="Euphemia"/>
+        <a:font script="Cher" typeface="Plantagenet Cherokee"/>
+        <a:font script="Yiii" typeface="Microsoft Yi Baiti"/>
+        <a:font script="Tibt" typeface="Microsoft Himalaya"/>
+        <a:font script="Thaa" typeface="MV Boli"/>
+        <a:font script="Deva" typeface="Mangal"/>
+        <a:font script="Telu" typeface="Gautami"/>
+        <a:font script="Taml" typeface="Latha"/>
+        <a:font script="Syrc" typeface="Estrangelo Edessa"/>
+        <a:font script="Orya" typeface="Kalinga"/>
+        <a:font script="Mlym" typeface="Kartika"/>
+        <a:font script="Laoo" typeface="DokChampa"/>
+        <a:font script="Sinh" typeface="Iskoola Pota"/>
+        <a:font script="Mong" typeface="Mongolian Baiti"/>
+        <a:font script="Viet" typeface="Arial"/>
+        <a:font script="Uigh" typeface="Microsoft Uighur"/>
+        <a:font script="Geor" typeface="Sylfaen"/>
+        <a:font script="Armn" typeface="Arial"/>
+        <a:font script="Bugi" typeface="Leelawadee UI"/>
+        <a:font script="Bopo" typeface="Microsoft JhengHei"/>
+        <a:font script="Java" typeface="Javanese Text"/>
+        <a:font script="Lisu" typeface="Segoe UI"/>
+        <a:font script="Mymr" typeface="Myanmar Text"/>
+        <a:font script="Nkoo" typeface="Ebrima"/>
+        <a:font script="Olck" typeface="Nirmala UI"/>
+        <a:font script="Osma" typeface="Ebrima"/>
+        <a:font script="Phag" typeface="Phagspa"/>
+        <a:font script="Syrn" typeface="Estrangelo Edessa"/>
+        <a:font script="Syrj" typeface="Estrangelo Edessa"/>
+        <a:font script="Syre" typeface="Estrangelo Edessa"/>
+        <a:font script="Sora" typeface="Nirmala UI"/>
+        <a:font script="Tale" typeface="Microsoft Tai Le"/>
+        <a:font script="Talu" typeface="Microsoft New Tai Lue"/>
+        <a:font script="Tfng" typeface="Ebrima"/>
+      </a:minorFont>
+    </a:fontScheme>
+    <a:fmtScheme name="Office">
+      <a:fillStyleLst>
+        <a:solidFill>
+          <a:schemeClr val="phClr"/>
+        </a:solidFill>
+        <a:gradFill rotWithShape="1">
+          <a:gsLst>
+            <a:gs pos="0">
+              <a:schemeClr val="phClr">
+                <a:lumMod val="110000"/>
+                <a:satMod val="105000"/>
+                <a:tint val="67000"/>
+              </a:schemeClr>
+            </a:gs>
+            <a:gs pos="50000">
+              <a:schemeClr val="phClr">
+                <a:lumMod val="105000"/>
+                <a:satMod val="103000"/>
+                <a:tint val="73000"/>
+              </a:schemeClr>
+            </a:gs>
+            <a:gs pos="100000">
+              <a:schemeClr val="phClr">
+                <a:lumMod val="105000"/>
+                <a:satMod val="109000"/>
+                <a:tint val="81000"/>
+              </a:schemeClr>
+            </a:gs>
+          </a:gsLst>
+          <a:lin ang="5400000" scaled="0"/>
+        </a:gradFill>
+        <a:gradFill rotWithShape="1">
+          <a:gsLst>
+            <a:gs pos="0">
+              <a:schemeClr val="phClr">
+                <a:satMod val="103000"/>
+                <a:lumMod val="102000"/>
+                <a:tint val="94000"/>
+              </a:schemeClr>
+            </a:gs>
+            <a:gs pos="50000">
+              <a:schemeClr val="phClr">
+                <a:satMod val="110000"/>
+                <a:lumMod val="100000"/>
+                <a:shade val="100000"/>
+              </a:schemeClr>
+            </a:gs>
+            <a:gs pos="100000">
+              <a:schemeClr val="phClr">
+                <a:lumMod val="99000"/>
+                <a:satMod val="120000"/>
+                <a:shade val="78000"/>
+              </a:schemeClr>
+            </a:gs>
+          </a:gsLst>
+          <a:lin ang="5400000" scaled="0"/>
+        </a:gradFill>
+      </a:fillStyleLst>
+      <a:lnStyleLst>
+        <a:ln w="6350" cap="flat" cmpd="sng" algn="ctr">
+          <a:solidFill>
+            <a:schemeClr val="phClr"/>
+          </a:solidFill>
+          <a:prstDash val="solid"/>
+          <a:miter lim="800000"/>
+        </a:ln>
+        <a:ln w="12700" cap="flat" cmpd="sng" algn="ctr">
+          <a:solidFill>
+            <a:schemeClr val="phClr"/>
+          </a:solidFill>
+          <a:prstDash val="solid"/>
+          <a:miter lim="800000"/>
+        </a:ln>
+        <a:ln w="19050" cap="flat" cmpd="sng" algn="ctr">
+          <a:solidFill>
+            <a:schemeClr val="phClr"/>
+          </a:solidFill>
+          <a:prstDash val="solid"/>
+          <a:miter lim="800000"/>
+        </a:ln>
+      </a:lnStyleLst>
+      <a:effectStyleLst>
+        <a:effectStyle>
+          <a:effectLst/>
+        </a:effectStyle>
+        <a:effectStyle>
+          <a:effectLst/>
+        </a:effectStyle>
+        <a:effectStyle>
+          <a:effectLst>
+            <a:outerShdw blurRad="57150" dist="19050" dir="5400000" algn="ctr" rotWithShape="0">
+              <a:srgbClr val="000000">
+                <a:alpha val="63000"/>
+              </a:srgbClr>
+            </a:outerShdw>
+          </a:effectLst>
+        </a:effectStyle>
+      </a:effectStyleLst>
+      <a:bgFillStyleLst>
+        <a:solidFill>
+          <a:schemeClr val="phClr"/>
+        </a:solidFill>
+        <a:solidFill>
+          <a:schemeClr val="phClr">
+            <a:tint val="95000"/>
+            <a:satMod val="170000"/>
+          </a:schemeClr>
+        </a:solidFill>
+        <a:gradFill rotWithShape="1">
+          <a:gsLst>
+            <a:gs pos="0">
+              <a:schemeClr val="phClr">
+                <a:tint val="93000"/>
+                <a:satMod val="150000"/>
+                <a:shade val="98000"/>
+                <a:lumMod val="102000"/>
+              </a:schemeClr>
+            </a:gs>
+            <a:gs pos="50000">
+              <a:schemeClr val="phClr">
+                <a:tint val="98000"/>
+                <a:satMod val="130000"/>
+                <a:shade val="90000"/>
+                <a:lumMod val="103000"/>
+              </a:schemeClr>
+            </a:gs>
+            <a:gs pos="100000">
+              <a:schemeClr val="phClr">
+                <a:shade val="63000"/>
+                <a:satMod val="120000"/>
+              </a:schemeClr>
+            </a:gs>
+          </a:gsLst>
+          <a:lin ang="5400000" scaled="0"/>
+        </a:gradFill>
+      </a:bgFillStyleLst>
+    </a:fmtScheme>
+  </a:themeElements>
+  <a:objectDefaults/>
+  <a:extraClrSchemeLst/>
+  <a:extLst>
+    <a:ext uri="{05A4C25C-085E-4340-85A3-A5531E510DB2}">
+      <thm15:themeFamily xmlns:thm15="http://schemas.microsoft.com/office/thememl/2012/main" name="Office Theme" id="{62F939B6-93AF-4DB8-9C6B-D6C7DFDC589F}" vid="{4A3C46E8-61CC-4603-A589-7422A47A8E4A}"/>
+    </a:ext>
+  </a:extLst>
+</a:theme>
 </file>
</xml_diff>